<commit_message>
Updated .pptx file with research questions
</commit_message>
<xml_diff>
--- a/Project2_Powerpoint.pptx
+++ b/Project2_Powerpoint.pptx
@@ -292,6 +292,18 @@
           <a:bodyPr/>
           <a:lstStyle/>
           <a:p>
+            <a:r>
+              <a:rPr lang="en-US" sz="1200" b="0" i="0" u="none" strike="noStrike" kern="1200" dirty="0">
+                <a:solidFill>
+                  <a:schemeClr val="tx1"/>
+                </a:solidFill>
+                <a:effectLst/>
+                <a:latin typeface="+mn-lt"/>
+                <a:ea typeface="+mn-ea"/>
+                <a:cs typeface="+mn-cs"/>
+              </a:rPr>
+              <a:t>Today, I will be discussing our project on the injury risk in soccer players from universities. Our objective in undertaking this project is to gain insights into the causes of injury using data. This will enable us to find ways through which we can prevent injuries.</a:t>
+            </a:r>
             <a:endParaRPr lang="en-US" dirty="0"/>
           </a:p>
         </p:txBody>
@@ -394,6 +406,30 @@
           <a:bodyPr/>
           <a:lstStyle/>
           <a:p>
+            <a:r>
+              <a:rPr lang="en-US" sz="1200" b="0" i="0" u="none" strike="noStrike" kern="1200" dirty="0">
+                <a:solidFill>
+                  <a:schemeClr val="tx1"/>
+                </a:solidFill>
+                <a:effectLst/>
+                <a:latin typeface="+mn-lt"/>
+                <a:ea typeface="+mn-ea"/>
+                <a:cs typeface="+mn-cs"/>
+              </a:rPr>
+              <a:t>In general, it can be stated that a number of variables may increase the possibility of injuries. First of all, lifestyle-related characteristics, including stress, sleep problems, and improper nutrition, have been shown to significantly affect the chances of injuries. Second, the history of previous injuries plays an important role in predicting future injuries.</a:t>
+            </a:r>
+            <a:r>
+              <a:rPr lang="en-US" sz="1200" b="0" i="0" kern="1200" dirty="0">
+                <a:solidFill>
+                  <a:schemeClr val="tx1"/>
+                </a:solidFill>
+                <a:effectLst/>
+                <a:latin typeface="+mn-lt"/>
+                <a:ea typeface="+mn-ea"/>
+                <a:cs typeface="+mn-cs"/>
+              </a:rPr>
+              <a:t>​</a:t>
+            </a:r>
             <a:endParaRPr lang="en-US" dirty="0"/>
           </a:p>
         </p:txBody>
@@ -484,6 +520,30 @@
           <a:bodyPr/>
           <a:lstStyle/>
           <a:p>
+            <a:r>
+              <a:rPr lang="en-US" sz="1200" b="0" i="0" u="none" strike="noStrike" kern="1200" dirty="0">
+                <a:solidFill>
+                  <a:schemeClr val="tx1"/>
+                </a:solidFill>
+                <a:effectLst/>
+                <a:latin typeface="+mn-lt"/>
+                <a:ea typeface="+mn-ea"/>
+                <a:cs typeface="+mn-cs"/>
+              </a:rPr>
+              <a:t>Moreover, there are several ethical implications related to the use of this kind of information. Health-related data of athletes is extremely sensitive, and, therefore, security and privacy become crucial elements. Additionally, it is essential not to classify players as high-risk individuals and cause harm to them. The primary goal of such models is to assist in decision-making and not substitute humans, informing athletes of all data usage aspects.</a:t>
+            </a:r>
+            <a:r>
+              <a:rPr lang="en-US" sz="1200" b="0" i="0" kern="1200" dirty="0">
+                <a:solidFill>
+                  <a:schemeClr val="tx1"/>
+                </a:solidFill>
+                <a:effectLst/>
+                <a:latin typeface="+mn-lt"/>
+                <a:ea typeface="+mn-ea"/>
+                <a:cs typeface="+mn-cs"/>
+              </a:rPr>
+              <a:t>​</a:t>
+            </a:r>
             <a:endParaRPr lang="en-US" dirty="0"/>
           </a:p>
         </p:txBody>
@@ -586,6 +646,30 @@
           <a:bodyPr/>
           <a:lstStyle/>
           <a:p>
+            <a:r>
+              <a:rPr lang="en-US" sz="1200" b="0" i="0" u="none" strike="noStrike" kern="1200" dirty="0">
+                <a:solidFill>
+                  <a:schemeClr val="tx1"/>
+                </a:solidFill>
+                <a:effectLst/>
+                <a:latin typeface="+mn-lt"/>
+                <a:ea typeface="+mn-ea"/>
+                <a:cs typeface="+mn-cs"/>
+              </a:rPr>
+              <a:t>To conclude, this study offers important information that can assist in lowering injury rates among sportsmen and sport teams. Improved health results in improved performance and enjoyment on the part of sportsmen and spectators. This study can be further developed by considering several sport seasons and introducing the information gained into practice.</a:t>
+            </a:r>
+            <a:r>
+              <a:rPr lang="en-US" sz="1200" b="0" i="0" kern="1200" dirty="0">
+                <a:solidFill>
+                  <a:schemeClr val="tx1"/>
+                </a:solidFill>
+                <a:effectLst/>
+                <a:latin typeface="+mn-lt"/>
+                <a:ea typeface="+mn-ea"/>
+                <a:cs typeface="+mn-cs"/>
+              </a:rPr>
+              <a:t>​</a:t>
+            </a:r>
             <a:endParaRPr lang="en-US" dirty="0"/>
           </a:p>
         </p:txBody>
@@ -676,6 +760,18 @@
           <a:bodyPr/>
           <a:lstStyle/>
           <a:p>
+            <a:r>
+              <a:rPr lang="en-US" sz="1200" b="0" i="0" u="none" strike="noStrike" kern="1200" dirty="0">
+                <a:solidFill>
+                  <a:schemeClr val="tx1"/>
+                </a:solidFill>
+                <a:effectLst/>
+                <a:latin typeface="+mn-lt"/>
+                <a:ea typeface="+mn-ea"/>
+                <a:cs typeface="+mn-cs"/>
+              </a:rPr>
+              <a:t>The database consists of details about 800 university football players in China. The dataset is composed of 18 attributes that include basic physical characteristics of the participants such as age, height, and weight; fitness indicators such as agility and balance; factors related to training and lifestyle, such as sleeping patterns, stress level, and nutrition; and finally the presence of an injury among the players.</a:t>
+            </a:r>
             <a:endParaRPr lang="en-US" dirty="0"/>
           </a:p>
         </p:txBody>
@@ -760,6 +856,30 @@
           <a:bodyPr/>
           <a:lstStyle/>
           <a:p>
+            <a:r>
+              <a:rPr lang="en-US" sz="1200" b="0" i="0" u="none" strike="noStrike" kern="1200" dirty="0">
+                <a:solidFill>
+                  <a:schemeClr val="tx1"/>
+                </a:solidFill>
+                <a:effectLst/>
+                <a:latin typeface="+mn-lt"/>
+                <a:ea typeface="+mn-ea"/>
+                <a:cs typeface="+mn-cs"/>
+              </a:rPr>
+              <a:t>The primary objective of this study will be to investigate various determinants and the relationship of these with the likelihood of sustaining an injury, including training volume, past history of injuries, physical conditioning, and lifestyle practices. The purpose will be to determine those factors that have the greatest impact on injury incidence.</a:t>
+            </a:r>
+            <a:r>
+              <a:rPr lang="en-US" sz="1200" b="0" i="0" kern="1200" dirty="0">
+                <a:solidFill>
+                  <a:schemeClr val="tx1"/>
+                </a:solidFill>
+                <a:effectLst/>
+                <a:latin typeface="+mn-lt"/>
+                <a:ea typeface="+mn-ea"/>
+                <a:cs typeface="+mn-cs"/>
+              </a:rPr>
+              <a:t>​</a:t>
+            </a:r>
             <a:endParaRPr lang="en-US" dirty="0"/>
           </a:p>
         </p:txBody>
@@ -844,6 +964,30 @@
           <a:bodyPr/>
           <a:lstStyle/>
           <a:p>
+            <a:r>
+              <a:rPr lang="en-US" sz="1200" b="0" i="0" u="none" strike="noStrike" kern="1200" dirty="0">
+                <a:solidFill>
+                  <a:schemeClr val="tx1"/>
+                </a:solidFill>
+                <a:effectLst/>
+                <a:latin typeface="+mn-lt"/>
+                <a:ea typeface="+mn-ea"/>
+                <a:cs typeface="+mn-cs"/>
+              </a:rPr>
+              <a:t>This slide presents descriptive statistics of all numeric variables from the dataset. It allows us to grasp general characteristics of the data distribution, including means and ranges of different metrics. For instance, the slide demonstrates the mean number of hours spent on training, fitness scores, and many more interesting details. This part is essential as it creates a basis for further analysis.</a:t>
+            </a:r>
+            <a:r>
+              <a:rPr lang="en-US" sz="1200" b="0" i="0" kern="1200" dirty="0">
+                <a:solidFill>
+                  <a:schemeClr val="tx1"/>
+                </a:solidFill>
+                <a:effectLst/>
+                <a:latin typeface="+mn-lt"/>
+                <a:ea typeface="+mn-ea"/>
+                <a:cs typeface="+mn-cs"/>
+              </a:rPr>
+              <a:t>​</a:t>
+            </a:r>
             <a:endParaRPr lang="en-US" dirty="0"/>
           </a:p>
         </p:txBody>
@@ -928,6 +1072,30 @@
           <a:bodyPr/>
           <a:lstStyle/>
           <a:p>
+            <a:r>
+              <a:rPr lang="en-US" sz="1200" b="0" i="0" u="none" strike="noStrike" kern="1200" dirty="0">
+                <a:solidFill>
+                  <a:schemeClr val="tx1"/>
+                </a:solidFill>
+                <a:effectLst/>
+                <a:latin typeface="+mn-lt"/>
+                <a:ea typeface="+mn-ea"/>
+                <a:cs typeface="+mn-cs"/>
+              </a:rPr>
+              <a:t>Here, the distribution of key variables through histograms is considered. The majority of the key variables have a normal distribution pattern, meaning that the data set has a balanced distribution and is ideal for analysis. Moreover, this assists in determining the average value of key variables for players.</a:t>
+            </a:r>
+            <a:r>
+              <a:rPr lang="en-US" sz="1200" b="0" i="0" kern="1200" dirty="0">
+                <a:solidFill>
+                  <a:schemeClr val="tx1"/>
+                </a:solidFill>
+                <a:effectLst/>
+                <a:latin typeface="+mn-lt"/>
+                <a:ea typeface="+mn-ea"/>
+                <a:cs typeface="+mn-cs"/>
+              </a:rPr>
+              <a:t>​</a:t>
+            </a:r>
             <a:endParaRPr lang="en-US" dirty="0"/>
           </a:p>
         </p:txBody>
@@ -1012,6 +1180,30 @@
           <a:bodyPr/>
           <a:lstStyle/>
           <a:p>
+            <a:r>
+              <a:rPr lang="en-US" sz="1200" b="0" i="0" u="none" strike="noStrike" kern="1200" dirty="0">
+                <a:solidFill>
+                  <a:schemeClr val="tx1"/>
+                </a:solidFill>
+                <a:effectLst/>
+                <a:latin typeface="+mn-lt"/>
+                <a:ea typeface="+mn-ea"/>
+                <a:cs typeface="+mn-cs"/>
+              </a:rPr>
+              <a:t>The box plots show the comparison between players who were injured and those who were not. It is clear that there are notable differences between the two groups. The stress levels for players who sustained injuries are relatively higher, while their sleep and balance abilities are lower.</a:t>
+            </a:r>
+            <a:r>
+              <a:rPr lang="en-US" sz="1200" b="0" i="0" kern="1200" dirty="0">
+                <a:solidFill>
+                  <a:schemeClr val="tx1"/>
+                </a:solidFill>
+                <a:effectLst/>
+                <a:latin typeface="+mn-lt"/>
+                <a:ea typeface="+mn-ea"/>
+                <a:cs typeface="+mn-cs"/>
+              </a:rPr>
+              <a:t>​</a:t>
+            </a:r>
             <a:endParaRPr lang="en-US" dirty="0"/>
           </a:p>
         </p:txBody>
@@ -1096,6 +1288,30 @@
           <a:bodyPr/>
           <a:lstStyle/>
           <a:p>
+            <a:r>
+              <a:rPr lang="en-US" sz="1200" b="0" i="0" u="none" strike="noStrike" kern="1200" dirty="0">
+                <a:solidFill>
+                  <a:schemeClr val="tx1"/>
+                </a:solidFill>
+                <a:effectLst/>
+                <a:latin typeface="+mn-lt"/>
+                <a:ea typeface="+mn-ea"/>
+                <a:cs typeface="+mn-cs"/>
+              </a:rPr>
+              <a:t>This correlation matrix demonstrates the relationship between various variables. The color red signifies a positive correlation, and the color blue shows a negative correlation. It is clear from this correlation matrix that high levels of stress increase the likelihood of injuries, while proper nutrition and healthy behaviors decrease the likelihood of injuries.</a:t>
+            </a:r>
+            <a:r>
+              <a:rPr lang="en-US" sz="1200" b="0" i="0" kern="1200" dirty="0">
+                <a:solidFill>
+                  <a:schemeClr val="tx1"/>
+                </a:solidFill>
+                <a:effectLst/>
+                <a:latin typeface="+mn-lt"/>
+                <a:ea typeface="+mn-ea"/>
+                <a:cs typeface="+mn-cs"/>
+              </a:rPr>
+              <a:t>​</a:t>
+            </a:r>
             <a:endParaRPr lang="en-US" dirty="0"/>
           </a:p>
         </p:txBody>
@@ -1180,6 +1396,30 @@
           <a:bodyPr/>
           <a:lstStyle/>
           <a:p>
+            <a:r>
+              <a:rPr lang="en-US" sz="1200" b="0" i="0" u="none" strike="noStrike" kern="1200" dirty="0">
+                <a:solidFill>
+                  <a:schemeClr val="tx1"/>
+                </a:solidFill>
+                <a:effectLst/>
+                <a:latin typeface="+mn-lt"/>
+                <a:ea typeface="+mn-ea"/>
+                <a:cs typeface="+mn-cs"/>
+              </a:rPr>
+              <a:t>These graphs provide a more in-depth understanding of the relationship between variables. For instance, we get to understand the relationship between stress and sleep and the difference between them depending on whether the athletes have sustained injuries.</a:t>
+            </a:r>
+            <a:r>
+              <a:rPr lang="en-US" sz="1200" b="0" i="0" kern="1200" dirty="0">
+                <a:solidFill>
+                  <a:schemeClr val="tx1"/>
+                </a:solidFill>
+                <a:effectLst/>
+                <a:latin typeface="+mn-lt"/>
+                <a:ea typeface="+mn-ea"/>
+                <a:cs typeface="+mn-cs"/>
+              </a:rPr>
+              <a:t>​</a:t>
+            </a:r>
             <a:endParaRPr lang="en-US" dirty="0"/>
           </a:p>
         </p:txBody>
@@ -1282,6 +1522,30 @@
           <a:bodyPr/>
           <a:lstStyle/>
           <a:p>
+            <a:r>
+              <a:rPr lang="en-US" sz="1200" b="0" i="0" u="none" strike="noStrike" kern="1200" dirty="0">
+                <a:solidFill>
+                  <a:schemeClr val="tx1"/>
+                </a:solidFill>
+                <a:effectLst/>
+                <a:latin typeface="+mn-lt"/>
+                <a:ea typeface="+mn-ea"/>
+                <a:cs typeface="+mn-cs"/>
+              </a:rPr>
+              <a:t>This slide presents injury incidence by playing positions. It is apparent that forwards and midfield players experience a higher rate of injuries than defenders and goalkeepers. This may be due to the fact that these players need to be faster and more mobile while playing.</a:t>
+            </a:r>
+            <a:r>
+              <a:rPr lang="en-US" sz="1200" b="0" i="0" kern="1200" dirty="0">
+                <a:solidFill>
+                  <a:schemeClr val="tx1"/>
+                </a:solidFill>
+                <a:effectLst/>
+                <a:latin typeface="+mn-lt"/>
+                <a:ea typeface="+mn-ea"/>
+                <a:cs typeface="+mn-cs"/>
+              </a:rPr>
+              <a:t>​</a:t>
+            </a:r>
             <a:endParaRPr lang="en-US" dirty="0"/>
           </a:p>
         </p:txBody>
@@ -3791,7 +4055,7 @@
               <a:buNone/>
             </a:pPr>
             <a:r>
-              <a:rPr lang="en-US" sz="2000" b="1" dirty="0">
+              <a:rPr lang="en-US" sz="3200" b="1" dirty="0">
                 <a:solidFill>
                   <a:srgbClr val="1B2A4A"/>
                 </a:solidFill>
@@ -3799,9 +4063,9 @@
                 <a:ea typeface="Calibri" pitchFamily="34" charset="-122"/>
                 <a:cs typeface="Calibri" pitchFamily="34" charset="-120"/>
               </a:rPr>
-              <a:t>Primary Goal</a:t>
-            </a:r>
-            <a:endParaRPr lang="en-US" sz="2000" dirty="0"/>
+              <a:t>Research Questions</a:t>
+            </a:r>
+            <a:endParaRPr lang="en-US" sz="3200" dirty="0"/>
           </a:p>
         </p:txBody>
       </p:sp>
@@ -3813,7 +4077,7 @@
         </p:nvSpPr>
         <p:spPr>
           <a:xfrm>
-            <a:off x="502920" y="2055114"/>
+            <a:off x="502920" y="2404973"/>
             <a:ext cx="8138160" cy="1371600"/>
           </a:xfrm>
           <a:prstGeom prst="rect">
@@ -3826,35 +4090,40 @@
           <a:bodyPr wrap="square" lIns="0" tIns="0" rIns="0" bIns="0" rtlCol="0" anchor="ctr"/>
           <a:lstStyle/>
           <a:p>
-            <a:pPr marL="285750" indent="-285750">
-              <a:buFont typeface="Arial" panose="020B0604020202020204" pitchFamily="34" charset="0"/>
-              <a:buChar char="•"/>
-            </a:pPr>
-            <a:r>
-              <a:rPr lang="en-US" dirty="0"/>
-              <a:t>The primary goal of this project is to explore how training load, previous injury history, physical fitness metrics, and lifestyle habits relate to injury risk in university soccer players.</a:t>
-            </a:r>
-          </a:p>
-          <a:p>
-            <a:pPr marL="285750" indent="-285750">
-              <a:buFont typeface="Arial" panose="020B0604020202020204" pitchFamily="34" charset="0"/>
-              <a:buChar char="•"/>
-            </a:pPr>
-            <a:r>
-              <a:rPr lang="en-US" dirty="0"/>
-              <a:t>This project aims to identify which factors appear most strongly associated with injuries and how those insights could support evidence-based prevention strategies. </a:t>
-            </a:r>
-          </a:p>
-          <a:p>
-            <a:pPr marL="285750" indent="-285750">
-              <a:buFont typeface="Arial" panose="020B0604020202020204" pitchFamily="34" charset="0"/>
-              <a:buChar char="•"/>
-            </a:pPr>
-            <a:r>
-              <a:rPr lang="en-US" dirty="0"/>
-              <a:t>By understanding these relationships, sports programs can develop targeted interventions to reduce injury rates and protect athlete health.</a:t>
-            </a:r>
-            <a:endParaRPr lang="en-US" sz="1300" dirty="0"/>
+            <a:pPr marL="342900" indent="-342900">
+              <a:buAutoNum type="arabicPeriod"/>
+            </a:pPr>
+            <a:r>
+              <a:rPr lang="en-US" sz="2400" dirty="0"/>
+              <a:t>Which physical characteristics and fitness measures are most strongly associated with an increased risk of future injury?</a:t>
+            </a:r>
+          </a:p>
+          <a:p>
+            <a:pPr marL="342900" indent="-342900">
+              <a:buAutoNum type="arabicPeriod"/>
+            </a:pPr>
+            <a:r>
+              <a:rPr lang="en-US" sz="2400" dirty="0"/>
+              <a:t>What lifestyle habits or routines are most strongly linked to an increased likelihood of future injury?</a:t>
+            </a:r>
+          </a:p>
+          <a:p>
+            <a:pPr marL="342900" indent="-342900">
+              <a:buAutoNum type="arabicPeriod"/>
+            </a:pPr>
+            <a:r>
+              <a:rPr lang="en-US" sz="2400" dirty="0"/>
+              <a:t>Does previous injury, poor warmup, or over-training actually raise the likelihood of an injury</a:t>
+            </a:r>
+          </a:p>
+          <a:p>
+            <a:pPr marL="342900" indent="-342900">
+              <a:buAutoNum type="arabicPeriod"/>
+            </a:pPr>
+            <a:r>
+              <a:rPr lang="en-US" sz="2400" dirty="0"/>
+              <a:t>Does a player's position put them at higher risk of an injury </a:t>
+            </a:r>
           </a:p>
         </p:txBody>
       </p:sp>

</xml_diff>